<commit_message>
slides(openbookqa): enlarge answers and simplify paper references
</commit_message>
<xml_diff>
--- a/slides/datasets-in-10-minutes-openbookqa.pptx
+++ b/slides/datasets-in-10-minutes-openbookqa.pptx
@@ -7651,8 +7651,8 @@
         </p:nvSpPr>
         <p:spPr>
           <a:xfrm>
-            <a:off x="6583680" y="1271016"/>
-            <a:ext cx="1965960" cy="201168"/>
+            <a:off x="5303520" y="1216152"/>
+            <a:ext cx="3246120" cy="384048"/>
           </a:xfrm>
           <a:prstGeom prst="rect">
             <a:avLst/>
@@ -7660,14 +7660,14 @@
           <a:noFill/>
         </p:spPr>
         <p:txBody>
-          <a:bodyPr wrap="square" lIns="0" rIns="0" tIns="0" bIns="0">
+          <a:bodyPr wrap="none" lIns="0" rIns="0" tIns="0" bIns="0">
             <a:noAutofit/>
           </a:bodyPr>
           <a:lstStyle/>
           <a:p>
-            <a:pPr algn="l">
-              <a:lnSpc>
-                <a:spcPct val="117000"/>
+            <a:pPr algn="r">
+              <a:lnSpc>
+                <a:spcPts val="2640"/>
               </a:lnSpc>
               <a:spcBef>
                 <a:spcPts val="0"/>
@@ -7684,7 +7684,7 @@
               </a:defRPr>
             </a:pPr>
             <a:r>
-              <a:rPr sz="1250" b="1" lang="ja-JP" altLang="en-US">
+              <a:rPr sz="2200" b="1" lang="ja-JP" altLang="en-US">
                 <a:solidFill>
                   <a:srgbClr val="2C9100"/>
                 </a:solidFill>
@@ -8078,8 +8078,8 @@
         </p:nvSpPr>
         <p:spPr>
           <a:xfrm>
-            <a:off x="6583680" y="1271016"/>
-            <a:ext cx="1965960" cy="201168"/>
+            <a:off x="5303520" y="1216152"/>
+            <a:ext cx="3246120" cy="384048"/>
           </a:xfrm>
           <a:prstGeom prst="rect">
             <a:avLst/>
@@ -8087,14 +8087,14 @@
           <a:noFill/>
         </p:spPr>
         <p:txBody>
-          <a:bodyPr wrap="square" lIns="0" rIns="0" tIns="0" bIns="0">
+          <a:bodyPr wrap="none" lIns="0" rIns="0" tIns="0" bIns="0">
             <a:noAutofit/>
           </a:bodyPr>
           <a:lstStyle/>
           <a:p>
-            <a:pPr algn="l">
-              <a:lnSpc>
-                <a:spcPct val="117000"/>
+            <a:pPr algn="r">
+              <a:lnSpc>
+                <a:spcPts val="2640"/>
               </a:lnSpc>
               <a:spcBef>
                 <a:spcPts val="0"/>
@@ -8111,7 +8111,7 @@
               </a:defRPr>
             </a:pPr>
             <a:r>
-              <a:rPr sz="1250" b="1" lang="ja-JP" altLang="en-US">
+              <a:rPr sz="2200" b="1" lang="ja-JP" altLang="en-US">
                 <a:solidFill>
                   <a:srgbClr val="2C9100"/>
                 </a:solidFill>
@@ -8629,8 +8629,8 @@
         </p:nvSpPr>
         <p:spPr>
           <a:xfrm>
-            <a:off x="6583680" y="1271016"/>
-            <a:ext cx="1965960" cy="201168"/>
+            <a:off x="5303520" y="1216152"/>
+            <a:ext cx="3246120" cy="384048"/>
           </a:xfrm>
           <a:prstGeom prst="rect">
             <a:avLst/>
@@ -8638,14 +8638,14 @@
           <a:noFill/>
         </p:spPr>
         <p:txBody>
-          <a:bodyPr wrap="square" lIns="0" rIns="0" tIns="0" bIns="0">
+          <a:bodyPr wrap="none" lIns="0" rIns="0" tIns="0" bIns="0">
             <a:noAutofit/>
           </a:bodyPr>
           <a:lstStyle/>
           <a:p>
-            <a:pPr algn="l">
-              <a:lnSpc>
-                <a:spcPct val="117000"/>
+            <a:pPr algn="r">
+              <a:lnSpc>
+                <a:spcPts val="2640"/>
               </a:lnSpc>
               <a:spcBef>
                 <a:spcPts val="0"/>
@@ -8662,7 +8662,7 @@
               </a:defRPr>
             </a:pPr>
             <a:r>
-              <a:rPr sz="1250" b="1" lang="ja-JP" altLang="en-US">
+              <a:rPr sz="2200" b="1" lang="ja-JP" altLang="en-US">
                 <a:solidFill>
                   <a:srgbClr val="2C9100"/>
                 </a:solidFill>
@@ -14974,8 +14974,8 @@
         </p:nvSpPr>
         <p:spPr>
           <a:xfrm>
-            <a:off x="6583680" y="1271016"/>
-            <a:ext cx="1965960" cy="201168"/>
+            <a:off x="5303520" y="1216152"/>
+            <a:ext cx="3246120" cy="384048"/>
           </a:xfrm>
           <a:prstGeom prst="rect">
             <a:avLst/>
@@ -14983,14 +14983,14 @@
           <a:noFill/>
         </p:spPr>
         <p:txBody>
-          <a:bodyPr wrap="square" lIns="0" rIns="0" tIns="0" bIns="0">
+          <a:bodyPr wrap="none" lIns="0" rIns="0" tIns="0" bIns="0">
             <a:noAutofit/>
           </a:bodyPr>
           <a:lstStyle/>
           <a:p>
-            <a:pPr algn="l">
-              <a:lnSpc>
-                <a:spcPct val="117000"/>
+            <a:pPr algn="r">
+              <a:lnSpc>
+                <a:spcPts val="2640"/>
               </a:lnSpc>
               <a:spcBef>
                 <a:spcPts val="0"/>
@@ -15007,7 +15007,7 @@
               </a:defRPr>
             </a:pPr>
             <a:r>
-              <a:rPr sz="1250" b="1" lang="ja-JP" altLang="en-US">
+              <a:rPr sz="2200" b="1" lang="ja-JP" altLang="en-US">
                 <a:solidFill>
                   <a:srgbClr val="2C9100"/>
                 </a:solidFill>
@@ -15649,8 +15649,8 @@
         </p:nvSpPr>
         <p:spPr>
           <a:xfrm>
-            <a:off x="6583680" y="1271016"/>
-            <a:ext cx="1965960" cy="201168"/>
+            <a:off x="5303520" y="1216152"/>
+            <a:ext cx="3246120" cy="384048"/>
           </a:xfrm>
           <a:prstGeom prst="rect">
             <a:avLst/>
@@ -15658,14 +15658,14 @@
           <a:noFill/>
         </p:spPr>
         <p:txBody>
-          <a:bodyPr wrap="square" lIns="0" rIns="0" tIns="0" bIns="0">
+          <a:bodyPr wrap="none" lIns="0" rIns="0" tIns="0" bIns="0">
             <a:noAutofit/>
           </a:bodyPr>
           <a:lstStyle/>
           <a:p>
-            <a:pPr algn="l">
-              <a:lnSpc>
-                <a:spcPct val="117000"/>
+            <a:pPr algn="r">
+              <a:lnSpc>
+                <a:spcPts val="2640"/>
               </a:lnSpc>
               <a:spcBef>
                 <a:spcPts val="0"/>
@@ -15682,7 +15682,7 @@
               </a:defRPr>
             </a:pPr>
             <a:r>
-              <a:rPr sz="1250" b="1" lang="ja-JP" altLang="en-US">
+              <a:rPr sz="2200" b="1" lang="ja-JP" altLang="en-US">
                 <a:solidFill>
                   <a:srgbClr val="2C9100"/>
                 </a:solidFill>
@@ -16076,8 +16076,8 @@
         </p:nvSpPr>
         <p:spPr>
           <a:xfrm>
-            <a:off x="6583680" y="1271016"/>
-            <a:ext cx="1965960" cy="201168"/>
+            <a:off x="5303520" y="1216152"/>
+            <a:ext cx="3246120" cy="384048"/>
           </a:xfrm>
           <a:prstGeom prst="rect">
             <a:avLst/>
@@ -16085,14 +16085,14 @@
           <a:noFill/>
         </p:spPr>
         <p:txBody>
-          <a:bodyPr wrap="square" lIns="0" rIns="0" tIns="0" bIns="0">
+          <a:bodyPr wrap="none" lIns="0" rIns="0" tIns="0" bIns="0">
             <a:noAutofit/>
           </a:bodyPr>
           <a:lstStyle/>
           <a:p>
-            <a:pPr algn="l">
-              <a:lnSpc>
-                <a:spcPct val="117000"/>
+            <a:pPr algn="r">
+              <a:lnSpc>
+                <a:spcPts val="2640"/>
               </a:lnSpc>
               <a:spcBef>
                 <a:spcPts val="0"/>
@@ -16109,7 +16109,7 @@
               </a:defRPr>
             </a:pPr>
             <a:r>
-              <a:rPr sz="1250" b="1" lang="ja-JP" altLang="en-US">
+              <a:rPr sz="2200" b="1" lang="ja-JP" altLang="en-US">
                 <a:solidFill>
                   <a:srgbClr val="2C9100"/>
                 </a:solidFill>
@@ -16751,8 +16751,8 @@
         </p:nvSpPr>
         <p:spPr>
           <a:xfrm>
-            <a:off x="6583680" y="1271016"/>
-            <a:ext cx="1965960" cy="201168"/>
+            <a:off x="5303520" y="1216152"/>
+            <a:ext cx="3246120" cy="384048"/>
           </a:xfrm>
           <a:prstGeom prst="rect">
             <a:avLst/>
@@ -16760,14 +16760,14 @@
           <a:noFill/>
         </p:spPr>
         <p:txBody>
-          <a:bodyPr wrap="square" lIns="0" rIns="0" tIns="0" bIns="0">
+          <a:bodyPr wrap="none" lIns="0" rIns="0" tIns="0" bIns="0">
             <a:noAutofit/>
           </a:bodyPr>
           <a:lstStyle/>
           <a:p>
-            <a:pPr algn="l">
-              <a:lnSpc>
-                <a:spcPct val="117000"/>
+            <a:pPr algn="r">
+              <a:lnSpc>
+                <a:spcPts val="2640"/>
               </a:lnSpc>
               <a:spcBef>
                 <a:spcPts val="0"/>
@@ -16784,7 +16784,7 @@
               </a:defRPr>
             </a:pPr>
             <a:r>
-              <a:rPr sz="1250" b="1" lang="ja-JP" altLang="en-US">
+              <a:rPr sz="2200" b="1" lang="ja-JP" altLang="en-US">
                 <a:solidFill>
                   <a:srgbClr val="2C9100"/>
                 </a:solidFill>
@@ -17178,8 +17178,8 @@
         </p:nvSpPr>
         <p:spPr>
           <a:xfrm>
-            <a:off x="6583680" y="1271016"/>
-            <a:ext cx="1965960" cy="201168"/>
+            <a:off x="5303520" y="1216152"/>
+            <a:ext cx="3246120" cy="384048"/>
           </a:xfrm>
           <a:prstGeom prst="rect">
             <a:avLst/>
@@ -17187,14 +17187,14 @@
           <a:noFill/>
         </p:spPr>
         <p:txBody>
-          <a:bodyPr wrap="square" lIns="0" rIns="0" tIns="0" bIns="0">
+          <a:bodyPr wrap="none" lIns="0" rIns="0" tIns="0" bIns="0">
             <a:noAutofit/>
           </a:bodyPr>
           <a:lstStyle/>
           <a:p>
-            <a:pPr algn="l">
-              <a:lnSpc>
-                <a:spcPct val="117000"/>
+            <a:pPr algn="r">
+              <a:lnSpc>
+                <a:spcPts val="2640"/>
               </a:lnSpc>
               <a:spcBef>
                 <a:spcPts val="0"/>
@@ -17211,7 +17211,7 @@
               </a:defRPr>
             </a:pPr>
             <a:r>
-              <a:rPr sz="1250" b="1" lang="ja-JP" altLang="en-US">
+              <a:rPr sz="2200" b="1" lang="ja-JP" altLang="en-US">
                 <a:solidFill>
                   <a:srgbClr val="2C9100"/>
                 </a:solidFill>
@@ -17915,8 +17915,8 @@
         </p:nvSpPr>
         <p:spPr>
           <a:xfrm>
-            <a:off x="6583680" y="1271016"/>
-            <a:ext cx="1965960" cy="201168"/>
+            <a:off x="5303520" y="1216152"/>
+            <a:ext cx="3246120" cy="384048"/>
           </a:xfrm>
           <a:prstGeom prst="rect">
             <a:avLst/>
@@ -17924,14 +17924,14 @@
           <a:noFill/>
         </p:spPr>
         <p:txBody>
-          <a:bodyPr wrap="square" lIns="0" rIns="0" tIns="0" bIns="0">
+          <a:bodyPr wrap="none" lIns="0" rIns="0" tIns="0" bIns="0">
             <a:noAutofit/>
           </a:bodyPr>
           <a:lstStyle/>
           <a:p>
-            <a:pPr algn="l">
-              <a:lnSpc>
-                <a:spcPct val="117000"/>
+            <a:pPr algn="r">
+              <a:lnSpc>
+                <a:spcPts val="2640"/>
               </a:lnSpc>
               <a:spcBef>
                 <a:spcPts val="0"/>
@@ -17948,7 +17948,7 @@
               </a:defRPr>
             </a:pPr>
             <a:r>
-              <a:rPr sz="1250" b="1" lang="ja-JP" altLang="en-US">
+              <a:rPr sz="2200" b="1" lang="ja-JP" altLang="en-US">
                 <a:solidFill>
                   <a:srgbClr val="2C9100"/>
                 </a:solidFill>
@@ -18652,8 +18652,8 @@
         </p:nvSpPr>
         <p:spPr>
           <a:xfrm>
-            <a:off x="6583680" y="1271016"/>
-            <a:ext cx="1965960" cy="201168"/>
+            <a:off x="5303520" y="1216152"/>
+            <a:ext cx="3246120" cy="384048"/>
           </a:xfrm>
           <a:prstGeom prst="rect">
             <a:avLst/>
@@ -18661,14 +18661,14 @@
           <a:noFill/>
         </p:spPr>
         <p:txBody>
-          <a:bodyPr wrap="square" lIns="0" rIns="0" tIns="0" bIns="0">
+          <a:bodyPr wrap="none" lIns="0" rIns="0" tIns="0" bIns="0">
             <a:noAutofit/>
           </a:bodyPr>
           <a:lstStyle/>
           <a:p>
-            <a:pPr algn="l">
-              <a:lnSpc>
-                <a:spcPct val="117000"/>
+            <a:pPr algn="r">
+              <a:lnSpc>
+                <a:spcPts val="2640"/>
               </a:lnSpc>
               <a:spcBef>
                 <a:spcPts val="0"/>
@@ -18685,7 +18685,7 @@
               </a:defRPr>
             </a:pPr>
             <a:r>
-              <a:rPr sz="1250" b="1" lang="ja-JP" altLang="en-US">
+              <a:rPr sz="2200" b="1" lang="ja-JP" altLang="en-US">
                 <a:solidFill>
                   <a:srgbClr val="2C9100"/>
                 </a:solidFill>
@@ -19327,8 +19327,8 @@
         </p:nvSpPr>
         <p:spPr>
           <a:xfrm>
-            <a:off x="6583680" y="1271016"/>
-            <a:ext cx="1965960" cy="201168"/>
+            <a:off x="5303520" y="1216152"/>
+            <a:ext cx="3246120" cy="384048"/>
           </a:xfrm>
           <a:prstGeom prst="rect">
             <a:avLst/>
@@ -19336,14 +19336,14 @@
           <a:noFill/>
         </p:spPr>
         <p:txBody>
-          <a:bodyPr wrap="square" lIns="0" rIns="0" tIns="0" bIns="0">
+          <a:bodyPr wrap="none" lIns="0" rIns="0" tIns="0" bIns="0">
             <a:noAutofit/>
           </a:bodyPr>
           <a:lstStyle/>
           <a:p>
-            <a:pPr algn="l">
-              <a:lnSpc>
-                <a:spcPct val="117000"/>
+            <a:pPr algn="r">
+              <a:lnSpc>
+                <a:spcPts val="2640"/>
               </a:lnSpc>
               <a:spcBef>
                 <a:spcPts val="0"/>
@@ -19360,7 +19360,7 @@
               </a:defRPr>
             </a:pPr>
             <a:r>
-              <a:rPr sz="1250" b="1" lang="ja-JP" altLang="en-US">
+              <a:rPr sz="2200" b="1" lang="ja-JP" altLang="en-US">
                 <a:solidFill>
                   <a:srgbClr val="2C9100"/>
                 </a:solidFill>
@@ -19754,8 +19754,8 @@
         </p:nvSpPr>
         <p:spPr>
           <a:xfrm>
-            <a:off x="6583680" y="1271016"/>
-            <a:ext cx="1965960" cy="201168"/>
+            <a:off x="5303520" y="1216152"/>
+            <a:ext cx="3246120" cy="384048"/>
           </a:xfrm>
           <a:prstGeom prst="rect">
             <a:avLst/>
@@ -19763,14 +19763,14 @@
           <a:noFill/>
         </p:spPr>
         <p:txBody>
-          <a:bodyPr wrap="square" lIns="0" rIns="0" tIns="0" bIns="0">
+          <a:bodyPr wrap="none" lIns="0" rIns="0" tIns="0" bIns="0">
             <a:noAutofit/>
           </a:bodyPr>
           <a:lstStyle/>
           <a:p>
-            <a:pPr algn="l">
-              <a:lnSpc>
-                <a:spcPct val="117000"/>
+            <a:pPr algn="r">
+              <a:lnSpc>
+                <a:spcPts val="2640"/>
               </a:lnSpc>
               <a:spcBef>
                 <a:spcPts val="0"/>
@@ -19787,7 +19787,7 @@
               </a:defRPr>
             </a:pPr>
             <a:r>
-              <a:rPr sz="1250" b="1" lang="ja-JP" altLang="en-US">
+              <a:rPr sz="2200" b="1" lang="ja-JP" altLang="en-US">
                 <a:solidFill>
                   <a:srgbClr val="2C9100"/>
                 </a:solidFill>
@@ -20491,8 +20491,8 @@
         </p:nvSpPr>
         <p:spPr>
           <a:xfrm>
-            <a:off x="6583680" y="1271016"/>
-            <a:ext cx="1965960" cy="201168"/>
+            <a:off x="5303520" y="1216152"/>
+            <a:ext cx="3246120" cy="384048"/>
           </a:xfrm>
           <a:prstGeom prst="rect">
             <a:avLst/>
@@ -20500,14 +20500,14 @@
           <a:noFill/>
         </p:spPr>
         <p:txBody>
-          <a:bodyPr wrap="square" lIns="0" rIns="0" tIns="0" bIns="0">
+          <a:bodyPr wrap="none" lIns="0" rIns="0" tIns="0" bIns="0">
             <a:noAutofit/>
           </a:bodyPr>
           <a:lstStyle/>
           <a:p>
-            <a:pPr algn="l">
-              <a:lnSpc>
-                <a:spcPct val="117000"/>
+            <a:pPr algn="r">
+              <a:lnSpc>
+                <a:spcPts val="2640"/>
               </a:lnSpc>
               <a:spcBef>
                 <a:spcPts val="0"/>
@@ -20524,7 +20524,7 @@
               </a:defRPr>
             </a:pPr>
             <a:r>
-              <a:rPr sz="1250" b="1" lang="ja-JP" altLang="en-US">
+              <a:rPr sz="2200" b="1" lang="ja-JP" altLang="en-US">
                 <a:solidFill>
                   <a:srgbClr val="2C9100"/>
                 </a:solidFill>
@@ -21218,8 +21218,8 @@
         </p:nvSpPr>
         <p:spPr>
           <a:xfrm>
-            <a:off x="6583680" y="1271016"/>
-            <a:ext cx="1965960" cy="201168"/>
+            <a:off x="5303520" y="1216152"/>
+            <a:ext cx="3246120" cy="384048"/>
           </a:xfrm>
           <a:prstGeom prst="rect">
             <a:avLst/>
@@ -21227,14 +21227,14 @@
           <a:noFill/>
         </p:spPr>
         <p:txBody>
-          <a:bodyPr wrap="square" lIns="0" rIns="0" tIns="0" bIns="0">
+          <a:bodyPr wrap="none" lIns="0" rIns="0" tIns="0" bIns="0">
             <a:noAutofit/>
           </a:bodyPr>
           <a:lstStyle/>
           <a:p>
-            <a:pPr algn="l">
-              <a:lnSpc>
-                <a:spcPct val="117000"/>
+            <a:pPr algn="r">
+              <a:lnSpc>
+                <a:spcPts val="2640"/>
               </a:lnSpc>
               <a:spcBef>
                 <a:spcPts val="0"/>
@@ -21251,7 +21251,7 @@
               </a:defRPr>
             </a:pPr>
             <a:r>
-              <a:rPr sz="1250" b="1" lang="ja-JP" altLang="en-US">
+              <a:rPr sz="2200" b="1" lang="ja-JP" altLang="en-US">
                 <a:solidFill>
                   <a:srgbClr val="2C9100"/>
                 </a:solidFill>
@@ -21707,8 +21707,8 @@
         </p:nvSpPr>
         <p:spPr>
           <a:xfrm>
-            <a:off x="6583680" y="1271016"/>
-            <a:ext cx="1965960" cy="201168"/>
+            <a:off x="5303520" y="1216152"/>
+            <a:ext cx="3246120" cy="384048"/>
           </a:xfrm>
           <a:prstGeom prst="rect">
             <a:avLst/>
@@ -21716,14 +21716,14 @@
           <a:noFill/>
         </p:spPr>
         <p:txBody>
-          <a:bodyPr wrap="square" lIns="0" rIns="0" tIns="0" bIns="0">
+          <a:bodyPr wrap="none" lIns="0" rIns="0" tIns="0" bIns="0">
             <a:noAutofit/>
           </a:bodyPr>
           <a:lstStyle/>
           <a:p>
-            <a:pPr algn="l">
-              <a:lnSpc>
-                <a:spcPct val="117000"/>
+            <a:pPr algn="r">
+              <a:lnSpc>
+                <a:spcPts val="2640"/>
               </a:lnSpc>
               <a:spcBef>
                 <a:spcPts val="0"/>
@@ -21740,7 +21740,7 @@
               </a:defRPr>
             </a:pPr>
             <a:r>
-              <a:rPr sz="1250" b="1" lang="ja-JP" altLang="en-US">
+              <a:rPr sz="2200" b="1" lang="ja-JP" altLang="en-US">
                 <a:solidFill>
                   <a:srgbClr val="2C9100"/>
                 </a:solidFill>
@@ -22382,8 +22382,8 @@
         </p:nvSpPr>
         <p:spPr>
           <a:xfrm>
-            <a:off x="6583680" y="1271016"/>
-            <a:ext cx="1965960" cy="201168"/>
+            <a:off x="5303520" y="1216152"/>
+            <a:ext cx="3246120" cy="384048"/>
           </a:xfrm>
           <a:prstGeom prst="rect">
             <a:avLst/>
@@ -22391,14 +22391,14 @@
           <a:noFill/>
         </p:spPr>
         <p:txBody>
-          <a:bodyPr wrap="square" lIns="0" rIns="0" tIns="0" bIns="0">
+          <a:bodyPr wrap="none" lIns="0" rIns="0" tIns="0" bIns="0">
             <a:noAutofit/>
           </a:bodyPr>
           <a:lstStyle/>
           <a:p>
-            <a:pPr algn="l">
-              <a:lnSpc>
-                <a:spcPct val="117000"/>
+            <a:pPr algn="r">
+              <a:lnSpc>
+                <a:spcPts val="2640"/>
               </a:lnSpc>
               <a:spcBef>
                 <a:spcPts val="0"/>
@@ -22415,7 +22415,7 @@
               </a:defRPr>
             </a:pPr>
             <a:r>
-              <a:rPr sz="1250" b="1" lang="ja-JP" altLang="en-US">
+              <a:rPr sz="2200" b="1" lang="ja-JP" altLang="en-US">
                 <a:solidFill>
                   <a:srgbClr val="2C9100"/>
                 </a:solidFill>
@@ -22809,8 +22809,8 @@
         </p:nvSpPr>
         <p:spPr>
           <a:xfrm>
-            <a:off x="6583680" y="1271016"/>
-            <a:ext cx="1965960" cy="201168"/>
+            <a:off x="5303520" y="1216152"/>
+            <a:ext cx="3246120" cy="384048"/>
           </a:xfrm>
           <a:prstGeom prst="rect">
             <a:avLst/>
@@ -22818,14 +22818,14 @@
           <a:noFill/>
         </p:spPr>
         <p:txBody>
-          <a:bodyPr wrap="square" lIns="0" rIns="0" tIns="0" bIns="0">
+          <a:bodyPr wrap="none" lIns="0" rIns="0" tIns="0" bIns="0">
             <a:noAutofit/>
           </a:bodyPr>
           <a:lstStyle/>
           <a:p>
-            <a:pPr algn="l">
-              <a:lnSpc>
-                <a:spcPct val="117000"/>
+            <a:pPr algn="r">
+              <a:lnSpc>
+                <a:spcPts val="2640"/>
               </a:lnSpc>
               <a:spcBef>
                 <a:spcPts val="0"/>
@@ -22842,7 +22842,7 @@
               </a:defRPr>
             </a:pPr>
             <a:r>
-              <a:rPr sz="1250" b="1" lang="ja-JP" altLang="en-US">
+              <a:rPr sz="2200" b="1" lang="ja-JP" altLang="en-US">
                 <a:solidFill>
                   <a:srgbClr val="2C9100"/>
                 </a:solidFill>
@@ -23298,8 +23298,8 @@
         </p:nvSpPr>
         <p:spPr>
           <a:xfrm>
-            <a:off x="6583680" y="1271016"/>
-            <a:ext cx="1965960" cy="201168"/>
+            <a:off x="5303520" y="1216152"/>
+            <a:ext cx="3246120" cy="384048"/>
           </a:xfrm>
           <a:prstGeom prst="rect">
             <a:avLst/>
@@ -23307,14 +23307,14 @@
           <a:noFill/>
         </p:spPr>
         <p:txBody>
-          <a:bodyPr wrap="square" lIns="0" rIns="0" tIns="0" bIns="0">
+          <a:bodyPr wrap="none" lIns="0" rIns="0" tIns="0" bIns="0">
             <a:noAutofit/>
           </a:bodyPr>
           <a:lstStyle/>
           <a:p>
-            <a:pPr algn="l">
-              <a:lnSpc>
-                <a:spcPct val="117000"/>
+            <a:pPr algn="r">
+              <a:lnSpc>
+                <a:spcPts val="2640"/>
               </a:lnSpc>
               <a:spcBef>
                 <a:spcPts val="0"/>
@@ -23331,7 +23331,7 @@
               </a:defRPr>
             </a:pPr>
             <a:r>
-              <a:rPr sz="1250" b="1" lang="ja-JP" altLang="en-US">
+              <a:rPr sz="2200" b="1" lang="ja-JP" altLang="en-US">
                 <a:solidFill>
                   <a:srgbClr val="2C9100"/>
                 </a:solidFill>
@@ -23911,8 +23911,8 @@
         </p:nvSpPr>
         <p:spPr>
           <a:xfrm>
-            <a:off x="6583680" y="1271016"/>
-            <a:ext cx="1965960" cy="201168"/>
+            <a:off x="5303520" y="1216152"/>
+            <a:ext cx="3246120" cy="384048"/>
           </a:xfrm>
           <a:prstGeom prst="rect">
             <a:avLst/>
@@ -23920,14 +23920,14 @@
           <a:noFill/>
         </p:spPr>
         <p:txBody>
-          <a:bodyPr wrap="square" lIns="0" rIns="0" tIns="0" bIns="0">
+          <a:bodyPr wrap="none" lIns="0" rIns="0" tIns="0" bIns="0">
             <a:noAutofit/>
           </a:bodyPr>
           <a:lstStyle/>
           <a:p>
-            <a:pPr algn="l">
-              <a:lnSpc>
-                <a:spcPct val="117000"/>
+            <a:pPr algn="r">
+              <a:lnSpc>
+                <a:spcPts val="2640"/>
               </a:lnSpc>
               <a:spcBef>
                 <a:spcPts val="0"/>
@@ -23944,7 +23944,7 @@
               </a:defRPr>
             </a:pPr>
             <a:r>
-              <a:rPr sz="1250" b="1" lang="ja-JP" altLang="en-US">
+              <a:rPr sz="2200" b="1" lang="ja-JP" altLang="en-US">
                 <a:solidFill>
                   <a:srgbClr val="2C9100"/>
                 </a:solidFill>
@@ -27462,8 +27462,8 @@
         </p:nvSpPr>
         <p:spPr>
           <a:xfrm>
-            <a:off x="6583680" y="1271016"/>
-            <a:ext cx="1965960" cy="201168"/>
+            <a:off x="5303520" y="1216152"/>
+            <a:ext cx="3246120" cy="384048"/>
           </a:xfrm>
           <a:prstGeom prst="rect">
             <a:avLst/>
@@ -27471,14 +27471,14 @@
           <a:noFill/>
         </p:spPr>
         <p:txBody>
-          <a:bodyPr wrap="square" lIns="0" rIns="0" tIns="0" bIns="0">
+          <a:bodyPr wrap="none" lIns="0" rIns="0" tIns="0" bIns="0">
             <a:noAutofit/>
           </a:bodyPr>
           <a:lstStyle/>
           <a:p>
-            <a:pPr algn="l">
-              <a:lnSpc>
-                <a:spcPct val="117000"/>
+            <a:pPr algn="r">
+              <a:lnSpc>
+                <a:spcPts val="2640"/>
               </a:lnSpc>
               <a:spcBef>
                 <a:spcPts val="0"/>
@@ -27495,7 +27495,7 @@
               </a:defRPr>
             </a:pPr>
             <a:r>
-              <a:rPr sz="1250" b="1" lang="ja-JP" altLang="en-US">
+              <a:rPr sz="2200" b="1" lang="ja-JP" altLang="en-US">
                 <a:solidFill>
                   <a:srgbClr val="2C9100"/>
                 </a:solidFill>
@@ -27951,8 +27951,8 @@
         </p:nvSpPr>
         <p:spPr>
           <a:xfrm>
-            <a:off x="6583680" y="1271016"/>
-            <a:ext cx="1965960" cy="201168"/>
+            <a:off x="5303520" y="1216152"/>
+            <a:ext cx="3246120" cy="384048"/>
           </a:xfrm>
           <a:prstGeom prst="rect">
             <a:avLst/>
@@ -27960,14 +27960,14 @@
           <a:noFill/>
         </p:spPr>
         <p:txBody>
-          <a:bodyPr wrap="square" lIns="0" rIns="0" tIns="0" bIns="0">
+          <a:bodyPr wrap="none" lIns="0" rIns="0" tIns="0" bIns="0">
             <a:noAutofit/>
           </a:bodyPr>
           <a:lstStyle/>
           <a:p>
-            <a:pPr algn="l">
-              <a:lnSpc>
-                <a:spcPct val="117000"/>
+            <a:pPr algn="r">
+              <a:lnSpc>
+                <a:spcPts val="2640"/>
               </a:lnSpc>
               <a:spcBef>
                 <a:spcPts val="0"/>
@@ -27984,7 +27984,7 @@
               </a:defRPr>
             </a:pPr>
             <a:r>
-              <a:rPr sz="1250" b="1" lang="ja-JP" altLang="en-US">
+              <a:rPr sz="2200" b="1" lang="ja-JP" altLang="en-US">
                 <a:solidFill>
                   <a:srgbClr val="2C9100"/>
                 </a:solidFill>
@@ -28564,8 +28564,8 @@
         </p:nvSpPr>
         <p:spPr>
           <a:xfrm>
-            <a:off x="6583680" y="1271016"/>
-            <a:ext cx="1965960" cy="201168"/>
+            <a:off x="5303520" y="1216152"/>
+            <a:ext cx="3246120" cy="384048"/>
           </a:xfrm>
           <a:prstGeom prst="rect">
             <a:avLst/>
@@ -28573,14 +28573,14 @@
           <a:noFill/>
         </p:spPr>
         <p:txBody>
-          <a:bodyPr wrap="square" lIns="0" rIns="0" tIns="0" bIns="0">
+          <a:bodyPr wrap="none" lIns="0" rIns="0" tIns="0" bIns="0">
             <a:noAutofit/>
           </a:bodyPr>
           <a:lstStyle/>
           <a:p>
-            <a:pPr algn="l">
-              <a:lnSpc>
-                <a:spcPct val="117000"/>
+            <a:pPr algn="r">
+              <a:lnSpc>
+                <a:spcPts val="2640"/>
               </a:lnSpc>
               <a:spcBef>
                 <a:spcPts val="0"/>
@@ -28597,7 +28597,7 @@
               </a:defRPr>
             </a:pPr>
             <a:r>
-              <a:rPr sz="1250" b="1" lang="ja-JP" altLang="en-US">
+              <a:rPr sz="2200" b="1" lang="ja-JP" altLang="en-US">
                 <a:solidFill>
                   <a:srgbClr val="2C9100"/>
                 </a:solidFill>

</xml_diff>

<commit_message>
slides(openbookqa): use burgundy theme accent for answers
</commit_message>
<xml_diff>
--- a/slides/datasets-in-10-minutes-openbookqa.pptx
+++ b/slides/datasets-in-10-minutes-openbookqa.pptx
@@ -7686,7 +7686,7 @@
             <a:r>
               <a:rPr sz="2200" b="1" lang="ja-JP" altLang="en-US">
                 <a:solidFill>
-                  <a:srgbClr val="2C9100"/>
+                  <a:schemeClr val="accent1"/>
                 </a:solidFill>
                 <a:latin typeface="Noto Sans"/>
                 <a:ea typeface="Noto Sans CJK JP"/>
@@ -8113,7 +8113,7 @@
             <a:r>
               <a:rPr sz="2200" b="1" lang="ja-JP" altLang="en-US">
                 <a:solidFill>
-                  <a:srgbClr val="2C9100"/>
+                  <a:schemeClr val="accent1"/>
                 </a:solidFill>
                 <a:latin typeface="Noto Sans"/>
                 <a:ea typeface="Noto Sans CJK JP"/>
@@ -8664,7 +8664,7 @@
             <a:r>
               <a:rPr sz="2200" b="1" lang="ja-JP" altLang="en-US">
                 <a:solidFill>
-                  <a:srgbClr val="2C9100"/>
+                  <a:schemeClr val="accent1"/>
                 </a:solidFill>
                 <a:latin typeface="Noto Sans"/>
                 <a:ea typeface="Noto Sans CJK JP"/>
@@ -15009,7 +15009,7 @@
             <a:r>
               <a:rPr sz="2200" b="1" lang="ja-JP" altLang="en-US">
                 <a:solidFill>
-                  <a:srgbClr val="2C9100"/>
+                  <a:schemeClr val="accent1"/>
                 </a:solidFill>
                 <a:latin typeface="Noto Sans"/>
                 <a:ea typeface="Noto Sans CJK JP"/>
@@ -15684,7 +15684,7 @@
             <a:r>
               <a:rPr sz="2200" b="1" lang="ja-JP" altLang="en-US">
                 <a:solidFill>
-                  <a:srgbClr val="2C9100"/>
+                  <a:schemeClr val="accent1"/>
                 </a:solidFill>
                 <a:latin typeface="Noto Sans"/>
                 <a:ea typeface="Noto Sans CJK JP"/>
@@ -16111,7 +16111,7 @@
             <a:r>
               <a:rPr sz="2200" b="1" lang="ja-JP" altLang="en-US">
                 <a:solidFill>
-                  <a:srgbClr val="2C9100"/>
+                  <a:schemeClr val="accent1"/>
                 </a:solidFill>
                 <a:latin typeface="Noto Sans"/>
                 <a:ea typeface="Noto Sans CJK JP"/>
@@ -16786,7 +16786,7 @@
             <a:r>
               <a:rPr sz="2200" b="1" lang="ja-JP" altLang="en-US">
                 <a:solidFill>
-                  <a:srgbClr val="2C9100"/>
+                  <a:schemeClr val="accent1"/>
                 </a:solidFill>
                 <a:latin typeface="Noto Sans"/>
                 <a:ea typeface="Noto Sans CJK JP"/>
@@ -17213,7 +17213,7 @@
             <a:r>
               <a:rPr sz="2200" b="1" lang="ja-JP" altLang="en-US">
                 <a:solidFill>
-                  <a:srgbClr val="2C9100"/>
+                  <a:schemeClr val="accent1"/>
                 </a:solidFill>
                 <a:latin typeface="Noto Sans"/>
                 <a:ea typeface="Noto Sans CJK JP"/>
@@ -17950,7 +17950,7 @@
             <a:r>
               <a:rPr sz="2200" b="1" lang="ja-JP" altLang="en-US">
                 <a:solidFill>
-                  <a:srgbClr val="2C9100"/>
+                  <a:schemeClr val="accent1"/>
                 </a:solidFill>
                 <a:latin typeface="Noto Sans"/>
                 <a:ea typeface="Noto Sans CJK JP"/>
@@ -18687,7 +18687,7 @@
             <a:r>
               <a:rPr sz="2200" b="1" lang="ja-JP" altLang="en-US">
                 <a:solidFill>
-                  <a:srgbClr val="2C9100"/>
+                  <a:schemeClr val="accent1"/>
                 </a:solidFill>
                 <a:latin typeface="Noto Sans"/>
                 <a:ea typeface="Noto Sans CJK JP"/>
@@ -19362,7 +19362,7 @@
             <a:r>
               <a:rPr sz="2200" b="1" lang="ja-JP" altLang="en-US">
                 <a:solidFill>
-                  <a:srgbClr val="2C9100"/>
+                  <a:schemeClr val="accent1"/>
                 </a:solidFill>
                 <a:latin typeface="Noto Sans"/>
                 <a:ea typeface="Noto Sans CJK JP"/>
@@ -19789,7 +19789,7 @@
             <a:r>
               <a:rPr sz="2200" b="1" lang="ja-JP" altLang="en-US">
                 <a:solidFill>
-                  <a:srgbClr val="2C9100"/>
+                  <a:schemeClr val="accent1"/>
                 </a:solidFill>
                 <a:latin typeface="Noto Sans"/>
                 <a:ea typeface="Noto Sans CJK JP"/>
@@ -20526,7 +20526,7 @@
             <a:r>
               <a:rPr sz="2200" b="1" lang="ja-JP" altLang="en-US">
                 <a:solidFill>
-                  <a:srgbClr val="2C9100"/>
+                  <a:schemeClr val="accent1"/>
                 </a:solidFill>
                 <a:latin typeface="Noto Sans"/>
                 <a:ea typeface="Noto Sans CJK JP"/>
@@ -21253,7 +21253,7 @@
             <a:r>
               <a:rPr sz="2200" b="1" lang="ja-JP" altLang="en-US">
                 <a:solidFill>
-                  <a:srgbClr val="2C9100"/>
+                  <a:schemeClr val="accent1"/>
                 </a:solidFill>
                 <a:latin typeface="Noto Sans"/>
                 <a:ea typeface="Noto Sans CJK JP"/>
@@ -21742,7 +21742,7 @@
             <a:r>
               <a:rPr sz="2200" b="1" lang="ja-JP" altLang="en-US">
                 <a:solidFill>
-                  <a:srgbClr val="2C9100"/>
+                  <a:schemeClr val="accent1"/>
                 </a:solidFill>
                 <a:latin typeface="Noto Sans"/>
                 <a:ea typeface="Noto Sans CJK JP"/>
@@ -22417,7 +22417,7 @@
             <a:r>
               <a:rPr sz="2200" b="1" lang="ja-JP" altLang="en-US">
                 <a:solidFill>
-                  <a:srgbClr val="2C9100"/>
+                  <a:schemeClr val="accent1"/>
                 </a:solidFill>
                 <a:latin typeface="Noto Sans"/>
                 <a:ea typeface="Noto Sans CJK JP"/>
@@ -22844,7 +22844,7 @@
             <a:r>
               <a:rPr sz="2200" b="1" lang="ja-JP" altLang="en-US">
                 <a:solidFill>
-                  <a:srgbClr val="2C9100"/>
+                  <a:schemeClr val="accent1"/>
                 </a:solidFill>
                 <a:latin typeface="Noto Sans"/>
                 <a:ea typeface="Noto Sans CJK JP"/>
@@ -23333,7 +23333,7 @@
             <a:r>
               <a:rPr sz="2200" b="1" lang="ja-JP" altLang="en-US">
                 <a:solidFill>
-                  <a:srgbClr val="2C9100"/>
+                  <a:schemeClr val="accent1"/>
                 </a:solidFill>
                 <a:latin typeface="Noto Sans"/>
                 <a:ea typeface="Noto Sans CJK JP"/>
@@ -23946,7 +23946,7 @@
             <a:r>
               <a:rPr sz="2200" b="1" lang="ja-JP" altLang="en-US">
                 <a:solidFill>
-                  <a:srgbClr val="2C9100"/>
+                  <a:schemeClr val="accent1"/>
                 </a:solidFill>
                 <a:latin typeface="Noto Sans"/>
                 <a:ea typeface="Noto Sans CJK JP"/>
@@ -27497,7 +27497,7 @@
             <a:r>
               <a:rPr sz="2200" b="1" lang="ja-JP" altLang="en-US">
                 <a:solidFill>
-                  <a:srgbClr val="2C9100"/>
+                  <a:schemeClr val="accent1"/>
                 </a:solidFill>
                 <a:latin typeface="Noto Sans"/>
                 <a:ea typeface="Noto Sans CJK JP"/>
@@ -27986,7 +27986,7 @@
             <a:r>
               <a:rPr sz="2200" b="1" lang="ja-JP" altLang="en-US">
                 <a:solidFill>
-                  <a:srgbClr val="2C9100"/>
+                  <a:schemeClr val="accent1"/>
                 </a:solidFill>
                 <a:latin typeface="Noto Sans"/>
                 <a:ea typeface="Noto Sans CJK JP"/>
@@ -28599,7 +28599,7 @@
             <a:r>
               <a:rPr sz="2200" b="1" lang="ja-JP" altLang="en-US">
                 <a:solidFill>
-                  <a:srgbClr val="2C9100"/>
+                  <a:schemeClr val="accent1"/>
                 </a:solidFill>
                 <a:latin typeface="Noto Sans"/>
                 <a:ea typeface="Noto Sans CJK JP"/>

</xml_diff>